<commit_message>
grafana, alertas y un poquillo mas
</commit_message>
<xml_diff>
--- a/docs/presentacion/VoxChain-Reborn.pptx
+++ b/docs/presentacion/VoxChain-Reborn.pptx
@@ -934,7 +934,7 @@
           <a:lstStyle/>
           <a:p>
             <a:r>
-              <a:t>Resumo en tres cosas. Uno: el Proof of Work tiene un propósito, y cada requisito de la consigna responde a una regla de gobierno. Dos: está desplegado como en producción: dos clústers, sin llaves estáticas, destruido y recreado dos veces. Tres: está medido, 535 tests, 2,77x de escalado, y sabemos exactamente dónde están sus límites. Cualquier cosa que les haya mostrado la pueden reproducir con un solo comando: ./run.sh demo. Gracias, ¿preguntas?</a:t>
+              <a:t>Resumo en tres cosas. Uno: el Proof of Work tiene un propósito, y cada requisito de la consigna responde a una regla de gobierno. Dos: está desplegado como en producción: dos clústers, sin llaves estáticas, destruido y recreado dos veces. Tres: está medido, 666 tests, 2,77x de escalado, y sabemos exactamente dónde están sus límites. Cualquier cosa que les haya mostrado la pueden reproducir con un solo comando: ./run.sh demo. Gracias, ¿preguntas?</a:t>
             </a:r>
           </a:p>
         </p:txBody>
@@ -9420,7 +9420,7 @@
                 </a:solidFill>
                 <a:latin typeface="Inter"/>
               </a:rPr>
-              <a:t>La clave privada nunca sale de tu navegador.</a:t>
+              <a:t>La clave privada nunca sale de tu dispositivo.</a:t>
             </a:r>
           </a:p>
         </p:txBody>
@@ -9460,7 +9460,7 @@
                 </a:solidFill>
                 <a:latin typeface="Inter"/>
               </a:rPr>
-              <a:t>CryptoKey no extraíble  </a:t>
+              <a:t xml:space="preserve">Passkey o clave cifrada  </a:t>
             </a:r>
             <a:r>
               <a:rPr sz="1250" b="0" i="0">
@@ -9469,7 +9469,7 @@
                 </a:solidFill>
                 <a:latin typeface="Inter"/>
               </a:rPr>
-              <a:t>en IndexedDB: la app firma, pero no puede leerla.</a:t>
+              <a:t>cada firma pide huella, PIN o tu contraseña.</a:t>
             </a:r>
           </a:p>
           <a:p>
@@ -11134,7 +11134,7 @@
                 </a:solidFill>
                 <a:latin typeface="Inter"/>
               </a:rPr>
-              <a:t>535</a:t>
+              <a:t>666</a:t>
             </a:r>
           </a:p>
         </p:txBody>
@@ -13089,7 +13089,7 @@
                 </a:solidFill>
                 <a:latin typeface="Inter"/>
               </a:rPr>
-              <a:t>535 tests, 2,77x de escalado, y un informe con lo que el sistema no hace: Sybil, concentración, ventana única.</a:t>
+              <a:t>666 tests, 2,77x de escalado, y un informe con lo que el sistema no hace: Sybil, concentración, ventana única.</a:t>
             </a:r>
           </a:p>
         </p:txBody>

</xml_diff>